<commit_message>
sharing current update on webpages
</commit_message>
<xml_diff>
--- a/docs/Group7_Formative_Answers.pptx
+++ b/docs/Group7_Formative_Answers.pptx
@@ -117,6 +117,11 @@
       </a:defRPr>
     </a:lvl9pPr>
   </p:defaultTextStyle>
+  <p:extLst>
+    <p:ext uri="{EFAFB233-063F-42B5-8137-9DF3F51BA10A}">
+      <p15:sldGuideLst xmlns:p15="http://schemas.microsoft.com/office/powerpoint/2012/main"/>
+    </p:ext>
+  </p:extLst>
 </p:presentation>
 </file>
 
@@ -4127,6 +4132,48 @@
               <a:t> </a:t>
             </a:r>
           </a:p>
+          <a:p>
+            <a:pPr indent="-228600" algn="l">
+              <a:buFont typeface="Arial" panose="020B0604020202020204" pitchFamily="34" charset="0"/>
+              <a:buChar char="•"/>
+            </a:pPr>
+            <a:r>
+              <a:rPr lang="en-US" sz="1800" dirty="0" err="1">
+                <a:solidFill>
+                  <a:schemeClr val="tx2"/>
+                </a:solidFill>
+              </a:rPr>
+              <a:t>Github</a:t>
+            </a:r>
+            <a:r>
+              <a:rPr lang="en-US" sz="1800" dirty="0">
+                <a:solidFill>
+                  <a:schemeClr val="tx2"/>
+                </a:solidFill>
+              </a:rPr>
+              <a:t> repo link:</a:t>
+            </a:r>
+          </a:p>
+          <a:p>
+            <a:pPr algn="l"/>
+            <a:r>
+              <a:rPr lang="en-US" sz="1800" dirty="0">
+                <a:solidFill>
+                  <a:schemeClr val="tx2"/>
+                </a:solidFill>
+                <a:hlinkClick r:id="rId2"/>
+              </a:rPr>
+              <a:t>https://github.com/AzasangeT/LEARNER-SUPPORT-PORTAL</a:t>
+            </a:r>
+            <a:r>
+              <a:rPr lang="en-US" sz="1800" dirty="0">
+                <a:solidFill>
+                  <a:schemeClr val="tx2"/>
+                </a:solidFill>
+              </a:rPr>
+              <a:t> </a:t>
+            </a:r>
+          </a:p>
         </p:txBody>
       </p:sp>
       <p:grpSp>
@@ -6674,7 +6721,7 @@
                 <a14:useLocalDpi xmlns:a14="http://schemas.microsoft.com/office/drawing/2010/main" val="0"/>
               </a:ext>
               <a:ext uri="{96DAC541-7B7A-43D3-8B79-37D633B846F1}">
-                <asvg:svgBlip xmlns:asvg="http://schemas.microsoft.com/office/drawing/2016/SVG/main" r:embed="rId2"/>
+                <asvg:svgBlip xmlns:asvg="http://schemas.microsoft.com/office/drawing/2016/SVG/main" r:embed="rId3"/>
               </a:ext>
             </a:extLst>
           </a:blip>

</xml_diff>